<commit_message>
Walkthrough, deck and session kit brought current with dual-stack / End.DT46 (re-captured from the lab; IPv6-in-IPv6 capture, VPNv6 route, IPv6 VRF table added)
Co-Authored-By: Claude Opus 5 <noreply@anthropic.com>
</commit_message>
<xml_diff>
--- a/docs/session/slides.pptx
+++ b/docs/session/slides.pptx
@@ -5084,7 +5084,7 @@
                 </a:solidFill>
                 <a:latin typeface="Calibri"/>
               </a:rPr>
-              <a:t>uDT4 · tenant-b</a:t>
+              <a:t>uDT46 · tenant-b</a:t>
             </a:r>
           </a:p>
         </p:txBody>
@@ -8359,7 +8359,7 @@
                 </a:solidFill>
                 <a:latin typeface="Calibri"/>
               </a:rPr>
-              <a:t>A SID is an address that means "do this when you own me". End = forward. End.X = out this link. End.DT4 = strip the IPv6 header and look the inner IPv4 packet up in this VRF. A router that does not own the address just routes IPv6 — that is the entire core.</a:t>
+              <a:t>A SID is an address that means "do this when you own me". End = forward. End.X = out this link. End.DT46 = strip the IPv6 header and look the inner packet — IPv4 or IPv6 — up in this VRF. A router that does not own the address just routes IPv6 — that is the entire core.</a:t>
             </a:r>
           </a:p>
         </p:txBody>
@@ -8447,7 +8447,7 @@
                 </a:solidFill>
                 <a:latin typeface="Calibri"/>
               </a:rPr>
-              <a:t>4 data centres · 3 P routers · 2 tenants · 19 VMs on one host</a:t>
+              <a:t>4 data centres · 3 P routers · 2 dual-stack tenants · 19 VMs on one host</a:t>
             </a:r>
           </a:p>
         </p:txBody>
@@ -8469,7 +8469,7 @@
         <p:spPr>
           <a:xfrm>
             <a:off x="548640" y="1554480"/>
-            <a:ext cx="11064240" cy="5456053"/>
+            <a:ext cx="11064240" cy="5006569"/>
           </a:xfrm>
           <a:prstGeom prst="rect">
             <a:avLst/>
@@ -8942,7 +8942,7 @@
                 </a:solidFill>
                 <a:latin typeface="Calibri"/>
               </a:rPr>
-              <a:t>function: End.DT4, tenant-a</a:t>
+              <a:t>function: End.DT46, tenant-a</a:t>
             </a:r>
           </a:p>
         </p:txBody>
@@ -9105,7 +9105,7 @@
                 </a:solidFill>
                 <a:latin typeface="Courier New"/>
               </a:rPr>
-              <a:t>fd00:c:3:e000::      pe3's End.DT4 for tenant-a (allocated by FRR at run time)</a:t>
+              <a:t>fd00:c:3:e000::      pe3's End.DT46 for tenant-a, IPv4 and IPv6 (allocated by FRR at run time)</a:t>
             </a:r>
           </a:p>
           <a:p>
@@ -9349,7 +9349,7 @@
                 </a:solidFill>
                 <a:latin typeface="Calibri"/>
               </a:rPr>
-              <a:t>seg6local routes on the owner only: End (uN) for the /48, one End.X (uA) per adjacency, one End.DT4 per tenant VRF on a PE. A P router has exactly the first two kinds.</a:t>
+              <a:t>seg6local routes on the owner only: End (uN) for the /48, one End.X (uA) per adjacency, one End.DT46 per tenant VRF on a PE. A P router has exactly the first two kinds.</a:t>
             </a:r>
           </a:p>
         </p:txBody>
@@ -9816,7 +9816,7 @@
                           </a:solidFill>
                           <a:latin typeface="Calibri"/>
                         </a:rPr>
-                        <a:t>End.DT4  (uDT4)</a:t>
+                        <a:t>End.DT46  (uDT46)</a:t>
                       </a:r>
                     </a:p>
                   </a:txBody>
@@ -9838,7 +9838,7 @@
                           </a:solidFill>
                           <a:latin typeface="Courier New"/>
                         </a:rPr>
-                        <a:t>fd00:c:1:e001::</a:t>
+                        <a:t>fd00:c:1:e000::</a:t>
                       </a:r>
                     </a:p>
                   </a:txBody>
@@ -9860,7 +9860,7 @@
                           </a:solidFill>
                           <a:latin typeface="Calibri"/>
                         </a:rPr>
-                        <a:t>decapsulate; route the inner IPv4 packet in VRF tenant-a</a:t>
+                        <a:t>decapsulate; route the inner IPv4 or IPv6 packet in VRF tenant-a</a:t>
                       </a:r>
                     </a:p>
                   </a:txBody>
@@ -9882,7 +9882,7 @@
                           </a:solidFill>
                           <a:latin typeface="Calibri"/>
                         </a:rPr>
-                        <a:t>bgpd (sid vpn export auto)</a:t>
+                        <a:t>bgpd (sid vpn per-vrf export auto)</a:t>
                       </a:r>
                     </a:p>
                   </a:txBody>
@@ -10092,7 +10092,7 @@
                 </a:solidFill>
                 <a:latin typeface="Calibri"/>
               </a:rPr>
-              <a:t>Whiteboard 2 — a SID where the label used to be</a:t>
+              <a:t>Whiteboard 2 — a SID where the label used to be; VPNv4 and VPNv6 share it</a:t>
             </a:r>
           </a:p>
         </p:txBody>
@@ -10731,7 +10731,7 @@
                 </a:solidFill>
                 <a:latin typeface="Calibri"/>
               </a:rPr>
-              <a:t>VPNv4 over IPv6 loopback sessions (extended next hop), every PE to both reflectors</a:t>
+              <a:t>VPNv4 + VPNv6 over IPv6 loopback sessions (extended next hop), every PE to both reflectors</a:t>
             </a:r>
           </a:p>
         </p:txBody>
@@ -11091,7 +11091,7 @@
                 </a:solidFill>
                 <a:latin typeface="Calibri"/>
               </a:rPr>
-              <a:t>The transport attribute: Prefix-SID instead of a label. No LFIB anywhere.</a:t>
+              <a:t>The transport attribute: Prefix-SID instead of a label. One End.DT46 per VRF serves IPv4 and IPv6. No LFIB anywhere.</a:t>
             </a:r>
           </a:p>
         </p:txBody>
@@ -11574,7 +11574,7 @@
                 </a:solidFill>
                 <a:latin typeface="Calibri"/>
               </a:rPr>
-              <a:t>The destination address is the whole instruction: pe3's End.DT4 for tenant-a. Out eth2 because pe3's locator is shortest via p2.</a:t>
+              <a:t>The destination address is the whole instruction: pe3's End.DT46 for tenant-a — the same one the IPv6 LAN uses. Out eth2 because pe3's locator is shortest via p2.</a:t>
             </a:r>
           </a:p>
         </p:txBody>
@@ -12614,7 +12614,7 @@
                 </a:solidFill>
                 <a:latin typeface="Courier New"/>
               </a:rPr>
-              <a:t>End.DT4</a:t>
+              <a:t>End.DT46</a:t>
             </a:r>
           </a:p>
         </p:txBody>
@@ -13413,7 +13413,7 @@
                 </a:solidFill>
                 <a:latin typeface="Arial"/>
               </a:rPr>
-              <a:t>isolation</a:t>
+              <a:t>dual-stack</a:t>
             </a:r>
           </a:p>
         </p:txBody>
@@ -13448,7 +13448,7 @@
                 </a:solidFill>
                 <a:latin typeface="Calibri"/>
               </a:rPr>
-              <a:t>dc1-h1 → dc1-h2 (tenant-b, same site): 100 % loss. No route, no firewall.</a:t>
+              <a:t>fd00:20:1::2 → fd00:20:3::2 rides the same SID: IPv6 inside IPv6.</a:t>
             </a:r>
           </a:p>
         </p:txBody>
@@ -14116,7 +14116,7 @@
                 </a:solidFill>
                 <a:latin typeface="Calibri"/>
               </a:rPr>
-              <a:t>uDT4 · tenant-b</a:t>
+              <a:t>uDT46 · tenant-b</a:t>
             </a:r>
           </a:p>
         </p:txBody>
@@ -14685,7 +14685,7 @@
                 </a:solidFill>
                 <a:latin typeface="Calibri"/>
               </a:rPr>
-              <a:t>down to pe3's uDT4 — exactly what an unsteered packet carries</a:t>
+              <a:t>down to pe3's uDT46 — exactly what an unsteered packet carries</a:t>
             </a:r>
           </a:p>
         </p:txBody>

</xml_diff>